<commit_message>
Add interactive Prepositions & Phrasal Verbs practice module (28 items)
</commit_message>
<xml_diff>
--- a/Past_Simple_Tense_Presentation.pptx
+++ b/Past_Simple_Tense_Presentation.pptx
@@ -3463,7 +3463,50 @@
       <p:grpSpPr/>
       <p:sp>
         <p:nvSpPr>
-          <p:cNvPr id="2" name="TextBox 1"/>
+          <p:cNvPr id="2" name="Rectangle 1"/>
+          <p:cNvSpPr/>
+          <p:nvPr/>
+        </p:nvSpPr>
+        <p:spPr>
+          <a:xfrm>
+            <a:off x="0" y="0"/>
+            <a:ext cx="12191695" cy="6858000"/>
+          </a:xfrm>
+          <a:prstGeom prst="rect">
+            <a:avLst/>
+          </a:prstGeom>
+          <a:solidFill>
+            <a:srgbClr val="FFFFFF"/>
+          </a:solidFill>
+          <a:ln>
+            <a:noFill/>
+          </a:ln>
+        </p:spPr>
+        <p:style>
+          <a:lnRef idx="1">
+            <a:schemeClr val="accent1"/>
+          </a:lnRef>
+          <a:fillRef idx="3">
+            <a:schemeClr val="accent1"/>
+          </a:fillRef>
+          <a:effectRef idx="2">
+            <a:schemeClr val="accent1"/>
+          </a:effectRef>
+          <a:fontRef idx="minor">
+            <a:schemeClr val="lt1"/>
+          </a:fontRef>
+        </p:style>
+        <p:txBody>
+          <a:bodyPr rtlCol="0" anchor="ctr"/>
+          <a:lstStyle/>
+          <a:p>
+            <a:pPr algn="ctr"/>
+          </a:p>
+        </p:txBody>
+      </p:sp>
+      <p:sp>
+        <p:nvSpPr>
+          <p:cNvPr id="3" name="TextBox 2"/>
           <p:cNvSpPr txBox="1"/>
           <p:nvPr/>
         </p:nvSpPr>
@@ -3515,7 +3558,7 @@
       </p:sp>
       <p:sp>
         <p:nvSpPr>
-          <p:cNvPr id="3" name="TextBox 2"/>
+          <p:cNvPr id="4" name="TextBox 3"/>
           <p:cNvSpPr txBox="1"/>
           <p:nvPr/>
         </p:nvSpPr>
@@ -3551,7 +3594,7 @@
       </p:sp>
       <p:sp>
         <p:nvSpPr>
-          <p:cNvPr id="4" name="Rectangle 3"/>
+          <p:cNvPr id="5" name="Rectangle 4"/>
           <p:cNvSpPr/>
           <p:nvPr/>
         </p:nvSpPr>
@@ -3596,7 +3639,7 @@
       </p:sp>
       <p:sp>
         <p:nvSpPr>
-          <p:cNvPr id="5" name="Rounded Rectangle 4"/>
+          <p:cNvPr id="6" name="Rounded Rectangle 5"/>
           <p:cNvSpPr/>
           <p:nvPr/>
         </p:nvSpPr>
@@ -3667,7 +3710,7 @@
       </p:sp>
       <p:sp>
         <p:nvSpPr>
-          <p:cNvPr id="6" name="TextBox 5"/>
+          <p:cNvPr id="7" name="TextBox 6"/>
           <p:cNvSpPr txBox="1"/>
           <p:nvPr/>
         </p:nvSpPr>
@@ -3703,7 +3746,7 @@
       </p:sp>
       <p:sp>
         <p:nvSpPr>
-          <p:cNvPr id="7" name="Rounded Rectangle 6"/>
+          <p:cNvPr id="8" name="Rounded Rectangle 7"/>
           <p:cNvSpPr/>
           <p:nvPr/>
         </p:nvSpPr>
@@ -3778,7 +3821,7 @@
       </p:sp>
       <p:sp>
         <p:nvSpPr>
-          <p:cNvPr id="8" name="Rounded Rectangle 7"/>
+          <p:cNvPr id="9" name="Rounded Rectangle 8"/>
           <p:cNvSpPr/>
           <p:nvPr/>
         </p:nvSpPr>
@@ -3853,7 +3896,7 @@
       </p:sp>
       <p:sp>
         <p:nvSpPr>
-          <p:cNvPr id="9" name="Rounded Rectangle 8"/>
+          <p:cNvPr id="10" name="Rounded Rectangle 9"/>
           <p:cNvSpPr/>
           <p:nvPr/>
         </p:nvSpPr>
@@ -3928,7 +3971,7 @@
       </p:sp>
       <p:sp>
         <p:nvSpPr>
-          <p:cNvPr id="10" name="Rounded Rectangle 9"/>
+          <p:cNvPr id="11" name="Rounded Rectangle 10"/>
           <p:cNvSpPr/>
           <p:nvPr/>
         </p:nvSpPr>
@@ -4021,7 +4064,50 @@
       <p:grpSpPr/>
       <p:sp>
         <p:nvSpPr>
-          <p:cNvPr id="2" name="TextBox 1"/>
+          <p:cNvPr id="2" name="Rectangle 1"/>
+          <p:cNvSpPr/>
+          <p:nvPr/>
+        </p:nvSpPr>
+        <p:spPr>
+          <a:xfrm>
+            <a:off x="0" y="0"/>
+            <a:ext cx="12191695" cy="6858000"/>
+          </a:xfrm>
+          <a:prstGeom prst="rect">
+            <a:avLst/>
+          </a:prstGeom>
+          <a:solidFill>
+            <a:srgbClr val="FFFFFF"/>
+          </a:solidFill>
+          <a:ln>
+            <a:noFill/>
+          </a:ln>
+        </p:spPr>
+        <p:style>
+          <a:lnRef idx="1">
+            <a:schemeClr val="accent1"/>
+          </a:lnRef>
+          <a:fillRef idx="3">
+            <a:schemeClr val="accent1"/>
+          </a:fillRef>
+          <a:effectRef idx="2">
+            <a:schemeClr val="accent1"/>
+          </a:effectRef>
+          <a:fontRef idx="minor">
+            <a:schemeClr val="lt1"/>
+          </a:fontRef>
+        </p:style>
+        <p:txBody>
+          <a:bodyPr rtlCol="0" anchor="ctr"/>
+          <a:lstStyle/>
+          <a:p>
+            <a:pPr algn="ctr"/>
+          </a:p>
+        </p:txBody>
+      </p:sp>
+      <p:sp>
+        <p:nvSpPr>
+          <p:cNvPr id="3" name="TextBox 2"/>
           <p:cNvSpPr txBox="1"/>
           <p:nvPr/>
         </p:nvSpPr>
@@ -4073,7 +4159,7 @@
       </p:sp>
       <p:sp>
         <p:nvSpPr>
-          <p:cNvPr id="3" name="TextBox 2"/>
+          <p:cNvPr id="4" name="TextBox 3"/>
           <p:cNvSpPr txBox="1"/>
           <p:nvPr/>
         </p:nvSpPr>
@@ -4109,7 +4195,7 @@
       </p:sp>
       <p:sp>
         <p:nvSpPr>
-          <p:cNvPr id="4" name="Rectangle 3"/>
+          <p:cNvPr id="5" name="Rectangle 4"/>
           <p:cNvSpPr/>
           <p:nvPr/>
         </p:nvSpPr>
@@ -4154,7 +4240,7 @@
       </p:sp>
       <p:sp>
         <p:nvSpPr>
-          <p:cNvPr id="5" name="Rounded Rectangle 4"/>
+          <p:cNvPr id="6" name="Rounded Rectangle 5"/>
           <p:cNvSpPr/>
           <p:nvPr/>
         </p:nvSpPr>
@@ -4277,7 +4363,7 @@
       </p:sp>
       <p:sp>
         <p:nvSpPr>
-          <p:cNvPr id="6" name="Rounded Rectangle 5"/>
+          <p:cNvPr id="7" name="Rounded Rectangle 6"/>
           <p:cNvSpPr/>
           <p:nvPr/>
         </p:nvSpPr>
@@ -4400,7 +4486,7 @@
       </p:sp>
       <p:sp>
         <p:nvSpPr>
-          <p:cNvPr id="7" name="Rounded Rectangle 6"/>
+          <p:cNvPr id="8" name="Rounded Rectangle 7"/>
           <p:cNvSpPr/>
           <p:nvPr/>
         </p:nvSpPr>
@@ -4541,7 +4627,50 @@
       <p:grpSpPr/>
       <p:sp>
         <p:nvSpPr>
-          <p:cNvPr id="2" name="TextBox 1"/>
+          <p:cNvPr id="2" name="Rectangle 1"/>
+          <p:cNvSpPr/>
+          <p:nvPr/>
+        </p:nvSpPr>
+        <p:spPr>
+          <a:xfrm>
+            <a:off x="0" y="0"/>
+            <a:ext cx="12191695" cy="6858000"/>
+          </a:xfrm>
+          <a:prstGeom prst="rect">
+            <a:avLst/>
+          </a:prstGeom>
+          <a:solidFill>
+            <a:srgbClr val="FFFFFF"/>
+          </a:solidFill>
+          <a:ln>
+            <a:noFill/>
+          </a:ln>
+        </p:spPr>
+        <p:style>
+          <a:lnRef idx="1">
+            <a:schemeClr val="accent1"/>
+          </a:lnRef>
+          <a:fillRef idx="3">
+            <a:schemeClr val="accent1"/>
+          </a:fillRef>
+          <a:effectRef idx="2">
+            <a:schemeClr val="accent1"/>
+          </a:effectRef>
+          <a:fontRef idx="minor">
+            <a:schemeClr val="lt1"/>
+          </a:fontRef>
+        </p:style>
+        <p:txBody>
+          <a:bodyPr rtlCol="0" anchor="ctr"/>
+          <a:lstStyle/>
+          <a:p>
+            <a:pPr algn="ctr"/>
+          </a:p>
+        </p:txBody>
+      </p:sp>
+      <p:sp>
+        <p:nvSpPr>
+          <p:cNvPr id="3" name="TextBox 2"/>
           <p:cNvSpPr txBox="1"/>
           <p:nvPr/>
         </p:nvSpPr>
@@ -4593,7 +4722,7 @@
       </p:sp>
       <p:sp>
         <p:nvSpPr>
-          <p:cNvPr id="3" name="TextBox 2"/>
+          <p:cNvPr id="4" name="TextBox 3"/>
           <p:cNvSpPr txBox="1"/>
           <p:nvPr/>
         </p:nvSpPr>
@@ -4629,7 +4758,7 @@
       </p:sp>
       <p:sp>
         <p:nvSpPr>
-          <p:cNvPr id="4" name="Rectangle 3"/>
+          <p:cNvPr id="5" name="Rectangle 4"/>
           <p:cNvSpPr/>
           <p:nvPr/>
         </p:nvSpPr>
@@ -4674,7 +4803,7 @@
       </p:sp>
       <p:graphicFrame>
         <p:nvGraphicFramePr>
-          <p:cNvPr id="5" name="Table 4"/>
+          <p:cNvPr id="6" name="Table 5"/>
           <p:cNvGraphicFramePr>
             <a:graphicFrameLocks noGrp="1"/>
           </p:cNvGraphicFramePr>
@@ -4790,7 +4919,7 @@
                   </a:txBody>
                   <a:tcPr>
                     <a:solidFill>
-                      <a:srgbClr val="FFFFFF"/>
+                      <a:srgbClr val="F8FAFC"/>
                     </a:solidFill>
                   </a:tcPr>
                 </a:tc>
@@ -4814,7 +4943,7 @@
                   </a:txBody>
                   <a:tcPr>
                     <a:solidFill>
-                      <a:srgbClr val="FFFFFF"/>
+                      <a:srgbClr val="F8FAFC"/>
                     </a:solidFill>
                   </a:tcPr>
                 </a:tc>
@@ -4842,7 +4971,7 @@
                   </a:txBody>
                   <a:tcPr>
                     <a:solidFill>
-                      <a:srgbClr val="FFFFFF"/>
+                      <a:srgbClr val="F8FAFC"/>
                     </a:solidFill>
                   </a:tcPr>
                 </a:tc>
@@ -4946,7 +5075,7 @@
                   </a:txBody>
                   <a:tcPr>
                     <a:solidFill>
-                      <a:srgbClr val="FFFFFF"/>
+                      <a:srgbClr val="F8FAFC"/>
                     </a:solidFill>
                   </a:tcPr>
                 </a:tc>
@@ -4970,7 +5099,7 @@
                   </a:txBody>
                   <a:tcPr>
                     <a:solidFill>
-                      <a:srgbClr val="FFFFFF"/>
+                      <a:srgbClr val="F8FAFC"/>
                     </a:solidFill>
                   </a:tcPr>
                 </a:tc>
@@ -4998,7 +5127,7 @@
                   </a:txBody>
                   <a:tcPr>
                     <a:solidFill>
-                      <a:srgbClr val="FFFFFF"/>
+                      <a:srgbClr val="F8FAFC"/>
                     </a:solidFill>
                   </a:tcPr>
                 </a:tc>
@@ -5102,7 +5231,7 @@
                   </a:txBody>
                   <a:tcPr>
                     <a:solidFill>
-                      <a:srgbClr val="FFFFFF"/>
+                      <a:srgbClr val="F8FAFC"/>
                     </a:solidFill>
                   </a:tcPr>
                 </a:tc>
@@ -5126,7 +5255,7 @@
                   </a:txBody>
                   <a:tcPr>
                     <a:solidFill>
-                      <a:srgbClr val="FFFFFF"/>
+                      <a:srgbClr val="F8FAFC"/>
                     </a:solidFill>
                   </a:tcPr>
                 </a:tc>
@@ -5154,7 +5283,7 @@
                   </a:txBody>
                   <a:tcPr>
                     <a:solidFill>
-                      <a:srgbClr val="FFFFFF"/>
+                      <a:srgbClr val="F8FAFC"/>
                     </a:solidFill>
                   </a:tcPr>
                 </a:tc>
@@ -5183,7 +5312,50 @@
       <p:grpSpPr/>
       <p:sp>
         <p:nvSpPr>
-          <p:cNvPr id="2" name="TextBox 1"/>
+          <p:cNvPr id="2" name="Rectangle 1"/>
+          <p:cNvSpPr/>
+          <p:nvPr/>
+        </p:nvSpPr>
+        <p:spPr>
+          <a:xfrm>
+            <a:off x="0" y="0"/>
+            <a:ext cx="12191695" cy="6858000"/>
+          </a:xfrm>
+          <a:prstGeom prst="rect">
+            <a:avLst/>
+          </a:prstGeom>
+          <a:solidFill>
+            <a:srgbClr val="FFFFFF"/>
+          </a:solidFill>
+          <a:ln>
+            <a:noFill/>
+          </a:ln>
+        </p:spPr>
+        <p:style>
+          <a:lnRef idx="1">
+            <a:schemeClr val="accent1"/>
+          </a:lnRef>
+          <a:fillRef idx="3">
+            <a:schemeClr val="accent1"/>
+          </a:fillRef>
+          <a:effectRef idx="2">
+            <a:schemeClr val="accent1"/>
+          </a:effectRef>
+          <a:fontRef idx="minor">
+            <a:schemeClr val="lt1"/>
+          </a:fontRef>
+        </p:style>
+        <p:txBody>
+          <a:bodyPr rtlCol="0" anchor="ctr"/>
+          <a:lstStyle/>
+          <a:p>
+            <a:pPr algn="ctr"/>
+          </a:p>
+        </p:txBody>
+      </p:sp>
+      <p:sp>
+        <p:nvSpPr>
+          <p:cNvPr id="3" name="TextBox 2"/>
           <p:cNvSpPr txBox="1"/>
           <p:nvPr/>
         </p:nvSpPr>
@@ -5235,7 +5407,7 @@
       </p:sp>
       <p:sp>
         <p:nvSpPr>
-          <p:cNvPr id="3" name="TextBox 2"/>
+          <p:cNvPr id="4" name="TextBox 3"/>
           <p:cNvSpPr txBox="1"/>
           <p:nvPr/>
         </p:nvSpPr>
@@ -5271,7 +5443,7 @@
       </p:sp>
       <p:sp>
         <p:nvSpPr>
-          <p:cNvPr id="4" name="Rectangle 3"/>
+          <p:cNvPr id="5" name="Rectangle 4"/>
           <p:cNvSpPr/>
           <p:nvPr/>
         </p:nvSpPr>
@@ -5316,7 +5488,7 @@
       </p:sp>
       <p:graphicFrame>
         <p:nvGraphicFramePr>
-          <p:cNvPr id="5" name="Table 4"/>
+          <p:cNvPr id="6" name="Table 5"/>
           <p:cNvGraphicFramePr>
             <a:graphicFrameLocks noGrp="1"/>
           </p:cNvGraphicFramePr>
@@ -5432,7 +5604,7 @@
                   </a:txBody>
                   <a:tcPr>
                     <a:solidFill>
-                      <a:srgbClr val="FFFFFF"/>
+                      <a:srgbClr val="F8FAFC"/>
                     </a:solidFill>
                   </a:tcPr>
                 </a:tc>
@@ -5456,7 +5628,7 @@
                   </a:txBody>
                   <a:tcPr>
                     <a:solidFill>
-                      <a:srgbClr val="FFFFFF"/>
+                      <a:srgbClr val="F8FAFC"/>
                     </a:solidFill>
                   </a:tcPr>
                 </a:tc>
@@ -5480,7 +5652,7 @@
                   </a:txBody>
                   <a:tcPr>
                     <a:solidFill>
-                      <a:srgbClr val="FFFFFF"/>
+                      <a:srgbClr val="F8FAFC"/>
                     </a:solidFill>
                   </a:tcPr>
                 </a:tc>
@@ -5580,7 +5752,7 @@
                   </a:txBody>
                   <a:tcPr>
                     <a:solidFill>
-                      <a:srgbClr val="FFFFFF"/>
+                      <a:srgbClr val="F8FAFC"/>
                     </a:solidFill>
                   </a:tcPr>
                 </a:tc>
@@ -5604,7 +5776,7 @@
                   </a:txBody>
                   <a:tcPr>
                     <a:solidFill>
-                      <a:srgbClr val="FFFFFF"/>
+                      <a:srgbClr val="F8FAFC"/>
                     </a:solidFill>
                   </a:tcPr>
                 </a:tc>
@@ -5628,7 +5800,7 @@
                   </a:txBody>
                   <a:tcPr>
                     <a:solidFill>
-                      <a:srgbClr val="FFFFFF"/>
+                      <a:srgbClr val="F8FAFC"/>
                     </a:solidFill>
                   </a:tcPr>
                 </a:tc>
@@ -5728,7 +5900,7 @@
                   </a:txBody>
                   <a:tcPr>
                     <a:solidFill>
-                      <a:srgbClr val="FFFFFF"/>
+                      <a:srgbClr val="F8FAFC"/>
                     </a:solidFill>
                   </a:tcPr>
                 </a:tc>
@@ -5752,7 +5924,7 @@
                   </a:txBody>
                   <a:tcPr>
                     <a:solidFill>
-                      <a:srgbClr val="FFFFFF"/>
+                      <a:srgbClr val="F8FAFC"/>
                     </a:solidFill>
                   </a:tcPr>
                 </a:tc>
@@ -5776,7 +5948,7 @@
                   </a:txBody>
                   <a:tcPr>
                     <a:solidFill>
-                      <a:srgbClr val="FFFFFF"/>
+                      <a:srgbClr val="F8FAFC"/>
                     </a:solidFill>
                   </a:tcPr>
                 </a:tc>
@@ -5787,7 +5959,7 @@
       </p:graphicFrame>
       <p:graphicFrame>
         <p:nvGraphicFramePr>
-          <p:cNvPr id="6" name="Table 5"/>
+          <p:cNvPr id="7" name="Table 6"/>
           <p:cNvGraphicFramePr>
             <a:graphicFrameLocks noGrp="1"/>
           </p:cNvGraphicFramePr>
@@ -5903,7 +6075,7 @@
                   </a:txBody>
                   <a:tcPr>
                     <a:solidFill>
-                      <a:srgbClr val="FFFFFF"/>
+                      <a:srgbClr val="F8FAFC"/>
                     </a:solidFill>
                   </a:tcPr>
                 </a:tc>
@@ -5927,7 +6099,7 @@
                   </a:txBody>
                   <a:tcPr>
                     <a:solidFill>
-                      <a:srgbClr val="FFFFFF"/>
+                      <a:srgbClr val="F8FAFC"/>
                     </a:solidFill>
                   </a:tcPr>
                 </a:tc>
@@ -5951,7 +6123,7 @@
                   </a:txBody>
                   <a:tcPr>
                     <a:solidFill>
-                      <a:srgbClr val="FFFFFF"/>
+                      <a:srgbClr val="F8FAFC"/>
                     </a:solidFill>
                   </a:tcPr>
                 </a:tc>
@@ -6051,7 +6223,7 @@
                   </a:txBody>
                   <a:tcPr>
                     <a:solidFill>
-                      <a:srgbClr val="FFFFFF"/>
+                      <a:srgbClr val="F8FAFC"/>
                     </a:solidFill>
                   </a:tcPr>
                 </a:tc>
@@ -6075,7 +6247,7 @@
                   </a:txBody>
                   <a:tcPr>
                     <a:solidFill>
-                      <a:srgbClr val="FFFFFF"/>
+                      <a:srgbClr val="F8FAFC"/>
                     </a:solidFill>
                   </a:tcPr>
                 </a:tc>
@@ -6099,7 +6271,7 @@
                   </a:txBody>
                   <a:tcPr>
                     <a:solidFill>
-                      <a:srgbClr val="FFFFFF"/>
+                      <a:srgbClr val="F8FAFC"/>
                     </a:solidFill>
                   </a:tcPr>
                 </a:tc>
@@ -6199,7 +6371,7 @@
                   </a:txBody>
                   <a:tcPr>
                     <a:solidFill>
-                      <a:srgbClr val="FFFFFF"/>
+                      <a:srgbClr val="F8FAFC"/>
                     </a:solidFill>
                   </a:tcPr>
                 </a:tc>
@@ -6223,7 +6395,7 @@
                   </a:txBody>
                   <a:tcPr>
                     <a:solidFill>
-                      <a:srgbClr val="FFFFFF"/>
+                      <a:srgbClr val="F8FAFC"/>
                     </a:solidFill>
                   </a:tcPr>
                 </a:tc>
@@ -6247,7 +6419,7 @@
                   </a:txBody>
                   <a:tcPr>
                     <a:solidFill>
-                      <a:srgbClr val="FFFFFF"/>
+                      <a:srgbClr val="F8FAFC"/>
                     </a:solidFill>
                   </a:tcPr>
                 </a:tc>
@@ -6276,7 +6448,50 @@
       <p:grpSpPr/>
       <p:sp>
         <p:nvSpPr>
-          <p:cNvPr id="2" name="TextBox 1"/>
+          <p:cNvPr id="2" name="Rectangle 1"/>
+          <p:cNvSpPr/>
+          <p:nvPr/>
+        </p:nvSpPr>
+        <p:spPr>
+          <a:xfrm>
+            <a:off x="0" y="0"/>
+            <a:ext cx="12191695" cy="6858000"/>
+          </a:xfrm>
+          <a:prstGeom prst="rect">
+            <a:avLst/>
+          </a:prstGeom>
+          <a:solidFill>
+            <a:srgbClr val="FFFFFF"/>
+          </a:solidFill>
+          <a:ln>
+            <a:noFill/>
+          </a:ln>
+        </p:spPr>
+        <p:style>
+          <a:lnRef idx="1">
+            <a:schemeClr val="accent1"/>
+          </a:lnRef>
+          <a:fillRef idx="3">
+            <a:schemeClr val="accent1"/>
+          </a:fillRef>
+          <a:effectRef idx="2">
+            <a:schemeClr val="accent1"/>
+          </a:effectRef>
+          <a:fontRef idx="minor">
+            <a:schemeClr val="lt1"/>
+          </a:fontRef>
+        </p:style>
+        <p:txBody>
+          <a:bodyPr rtlCol="0" anchor="ctr"/>
+          <a:lstStyle/>
+          <a:p>
+            <a:pPr algn="ctr"/>
+          </a:p>
+        </p:txBody>
+      </p:sp>
+      <p:sp>
+        <p:nvSpPr>
+          <p:cNvPr id="3" name="TextBox 2"/>
           <p:cNvSpPr txBox="1"/>
           <p:nvPr/>
         </p:nvSpPr>
@@ -6328,7 +6543,7 @@
       </p:sp>
       <p:sp>
         <p:nvSpPr>
-          <p:cNvPr id="3" name="TextBox 2"/>
+          <p:cNvPr id="4" name="TextBox 3"/>
           <p:cNvSpPr txBox="1"/>
           <p:nvPr/>
         </p:nvSpPr>
@@ -6364,7 +6579,7 @@
       </p:sp>
       <p:sp>
         <p:nvSpPr>
-          <p:cNvPr id="4" name="Rectangle 3"/>
+          <p:cNvPr id="5" name="Rectangle 4"/>
           <p:cNvSpPr/>
           <p:nvPr/>
         </p:nvSpPr>
@@ -6409,7 +6624,7 @@
       </p:sp>
       <p:sp>
         <p:nvSpPr>
-          <p:cNvPr id="5" name="Rounded Rectangle 4"/>
+          <p:cNvPr id="6" name="Rounded Rectangle 5"/>
           <p:cNvSpPr/>
           <p:nvPr/>
         </p:nvSpPr>
@@ -6480,7 +6695,7 @@
       </p:sp>
       <p:sp>
         <p:nvSpPr>
-          <p:cNvPr id="6" name="Rounded Rectangle 5"/>
+          <p:cNvPr id="7" name="Rounded Rectangle 6"/>
           <p:cNvSpPr/>
           <p:nvPr/>
         </p:nvSpPr>
@@ -6497,7 +6712,7 @@
           </a:solidFill>
           <a:ln>
             <a:solidFill>
-              <a:srgbClr val="FCA5A5"/>
+              <a:srgbClr val="DC2626"/>
             </a:solidFill>
           </a:ln>
         </p:spPr>
@@ -6559,7 +6774,7 @@
       </p:sp>
       <p:sp>
         <p:nvSpPr>
-          <p:cNvPr id="7" name="Rounded Rectangle 6"/>
+          <p:cNvPr id="8" name="Rounded Rectangle 7"/>
           <p:cNvSpPr/>
           <p:nvPr/>
         </p:nvSpPr>
@@ -6576,7 +6791,7 @@
           </a:solidFill>
           <a:ln>
             <a:solidFill>
-              <a:srgbClr val="86EFAC"/>
+              <a:srgbClr val="16A34A"/>
             </a:solidFill>
           </a:ln>
         </p:spPr>
@@ -6656,7 +6871,50 @@
       <p:grpSpPr/>
       <p:sp>
         <p:nvSpPr>
-          <p:cNvPr id="2" name="TextBox 1"/>
+          <p:cNvPr id="2" name="Rectangle 1"/>
+          <p:cNvSpPr/>
+          <p:nvPr/>
+        </p:nvSpPr>
+        <p:spPr>
+          <a:xfrm>
+            <a:off x="0" y="0"/>
+            <a:ext cx="12191695" cy="6858000"/>
+          </a:xfrm>
+          <a:prstGeom prst="rect">
+            <a:avLst/>
+          </a:prstGeom>
+          <a:solidFill>
+            <a:srgbClr val="FFFFFF"/>
+          </a:solidFill>
+          <a:ln>
+            <a:noFill/>
+          </a:ln>
+        </p:spPr>
+        <p:style>
+          <a:lnRef idx="1">
+            <a:schemeClr val="accent1"/>
+          </a:lnRef>
+          <a:fillRef idx="3">
+            <a:schemeClr val="accent1"/>
+          </a:fillRef>
+          <a:effectRef idx="2">
+            <a:schemeClr val="accent1"/>
+          </a:effectRef>
+          <a:fontRef idx="minor">
+            <a:schemeClr val="lt1"/>
+          </a:fontRef>
+        </p:style>
+        <p:txBody>
+          <a:bodyPr rtlCol="0" anchor="ctr"/>
+          <a:lstStyle/>
+          <a:p>
+            <a:pPr algn="ctr"/>
+          </a:p>
+        </p:txBody>
+      </p:sp>
+      <p:sp>
+        <p:nvSpPr>
+          <p:cNvPr id="3" name="TextBox 2"/>
           <p:cNvSpPr txBox="1"/>
           <p:nvPr/>
         </p:nvSpPr>
@@ -6708,7 +6966,7 @@
       </p:sp>
       <p:sp>
         <p:nvSpPr>
-          <p:cNvPr id="3" name="TextBox 2"/>
+          <p:cNvPr id="4" name="TextBox 3"/>
           <p:cNvSpPr txBox="1"/>
           <p:nvPr/>
         </p:nvSpPr>
@@ -6744,7 +7002,7 @@
       </p:sp>
       <p:sp>
         <p:nvSpPr>
-          <p:cNvPr id="4" name="Rectangle 3"/>
+          <p:cNvPr id="5" name="Rectangle 4"/>
           <p:cNvSpPr/>
           <p:nvPr/>
         </p:nvSpPr>
@@ -6789,7 +7047,7 @@
       </p:sp>
       <p:sp>
         <p:nvSpPr>
-          <p:cNvPr id="5" name="TextBox 4"/>
+          <p:cNvPr id="6" name="TextBox 5"/>
           <p:cNvSpPr txBox="1"/>
           <p:nvPr/>
         </p:nvSpPr>
@@ -6825,7 +7083,7 @@
       </p:sp>
       <p:sp>
         <p:nvSpPr>
-          <p:cNvPr id="6" name="Rounded Rectangle 5"/>
+          <p:cNvPr id="7" name="Rounded Rectangle 6"/>
           <p:cNvSpPr/>
           <p:nvPr/>
         </p:nvSpPr>
@@ -6932,7 +7190,7 @@
       </p:sp>
       <p:sp>
         <p:nvSpPr>
-          <p:cNvPr id="7" name="Rounded Rectangle 6"/>
+          <p:cNvPr id="8" name="Rounded Rectangle 7"/>
           <p:cNvSpPr/>
           <p:nvPr/>
         </p:nvSpPr>
@@ -7039,7 +7297,7 @@
       </p:sp>
       <p:sp>
         <p:nvSpPr>
-          <p:cNvPr id="8" name="Rounded Rectangle 7"/>
+          <p:cNvPr id="9" name="Rounded Rectangle 8"/>
           <p:cNvSpPr/>
           <p:nvPr/>
         </p:nvSpPr>
@@ -7146,7 +7404,7 @@
       </p:sp>
       <p:sp>
         <p:nvSpPr>
-          <p:cNvPr id="9" name="Rounded Rectangle 8"/>
+          <p:cNvPr id="10" name="Rounded Rectangle 9"/>
           <p:cNvSpPr/>
           <p:nvPr/>
         </p:nvSpPr>
@@ -7163,7 +7421,7 @@
           </a:solidFill>
           <a:ln>
             <a:solidFill>
-              <a:srgbClr val="86EFAC"/>
+              <a:srgbClr val="16A34A"/>
             </a:solidFill>
           </a:ln>
         </p:spPr>
@@ -7219,7 +7477,50 @@
       <p:grpSpPr/>
       <p:sp>
         <p:nvSpPr>
-          <p:cNvPr id="2" name="TextBox 1"/>
+          <p:cNvPr id="2" name="Rectangle 1"/>
+          <p:cNvSpPr/>
+          <p:nvPr/>
+        </p:nvSpPr>
+        <p:spPr>
+          <a:xfrm>
+            <a:off x="0" y="0"/>
+            <a:ext cx="12191695" cy="6858000"/>
+          </a:xfrm>
+          <a:prstGeom prst="rect">
+            <a:avLst/>
+          </a:prstGeom>
+          <a:solidFill>
+            <a:srgbClr val="FFFFFF"/>
+          </a:solidFill>
+          <a:ln>
+            <a:noFill/>
+          </a:ln>
+        </p:spPr>
+        <p:style>
+          <a:lnRef idx="1">
+            <a:schemeClr val="accent1"/>
+          </a:lnRef>
+          <a:fillRef idx="3">
+            <a:schemeClr val="accent1"/>
+          </a:fillRef>
+          <a:effectRef idx="2">
+            <a:schemeClr val="accent1"/>
+          </a:effectRef>
+          <a:fontRef idx="minor">
+            <a:schemeClr val="lt1"/>
+          </a:fontRef>
+        </p:style>
+        <p:txBody>
+          <a:bodyPr rtlCol="0" anchor="ctr"/>
+          <a:lstStyle/>
+          <a:p>
+            <a:pPr algn="ctr"/>
+          </a:p>
+        </p:txBody>
+      </p:sp>
+      <p:sp>
+        <p:nvSpPr>
+          <p:cNvPr id="3" name="TextBox 2"/>
           <p:cNvSpPr txBox="1"/>
           <p:nvPr/>
         </p:nvSpPr>
@@ -7271,7 +7572,7 @@
       </p:sp>
       <p:sp>
         <p:nvSpPr>
-          <p:cNvPr id="3" name="TextBox 2"/>
+          <p:cNvPr id="4" name="TextBox 3"/>
           <p:cNvSpPr txBox="1"/>
           <p:nvPr/>
         </p:nvSpPr>
@@ -7307,7 +7608,7 @@
       </p:sp>
       <p:sp>
         <p:nvSpPr>
-          <p:cNvPr id="4" name="Rectangle 3"/>
+          <p:cNvPr id="5" name="Rectangle 4"/>
           <p:cNvSpPr/>
           <p:nvPr/>
         </p:nvSpPr>
@@ -7352,7 +7653,7 @@
       </p:sp>
       <p:sp>
         <p:nvSpPr>
-          <p:cNvPr id="5" name="Rounded Rectangle 4"/>
+          <p:cNvPr id="6" name="Rounded Rectangle 5"/>
           <p:cNvSpPr/>
           <p:nvPr/>
         </p:nvSpPr>
@@ -7369,7 +7670,7 @@
           </a:solidFill>
           <a:ln>
             <a:solidFill>
-              <a:srgbClr val="BBF7D0"/>
+              <a:srgbClr val="16A34A"/>
             </a:solidFill>
           </a:ln>
         </p:spPr>
@@ -7394,7 +7695,7 @@
             <a:pPr algn="ctr">
               <a:defRPr sz="1800" b="1">
                 <a:solidFill>
-                  <a:srgbClr val="166534"/>
+                  <a:srgbClr val="16A34A"/>
                 </a:solidFill>
                 <a:latin typeface="Sarabun"/>
               </a:defRPr>
@@ -7410,7 +7711,7 @@
               </a:spcBef>
               <a:defRPr sz="1400">
                 <a:solidFill>
-                  <a:srgbClr val="14532D"/>
+                  <a:srgbClr val="1E293B"/>
                 </a:solidFill>
                 <a:latin typeface="Sarabun"/>
               </a:defRPr>
@@ -7454,7 +7755,7 @@
               </a:spcBef>
               <a:defRPr sz="1400" b="1">
                 <a:solidFill>
-                  <a:srgbClr val="166534"/>
+                  <a:srgbClr val="16A34A"/>
                 </a:solidFill>
                 <a:latin typeface="Sarabun"/>
               </a:defRPr>
@@ -7471,7 +7772,7 @@
       </p:sp>
       <p:sp>
         <p:nvSpPr>
-          <p:cNvPr id="6" name="Rounded Rectangle 5"/>
+          <p:cNvPr id="7" name="Rounded Rectangle 6"/>
           <p:cNvSpPr/>
           <p:nvPr/>
         </p:nvSpPr>
@@ -7488,7 +7789,7 @@
           </a:solidFill>
           <a:ln>
             <a:solidFill>
-              <a:srgbClr val="FECACA"/>
+              <a:srgbClr val="DC2626"/>
             </a:solidFill>
           </a:ln>
         </p:spPr>
@@ -7513,7 +7814,7 @@
             <a:pPr algn="ctr">
               <a:defRPr sz="1800" b="1">
                 <a:solidFill>
-                  <a:srgbClr val="991B1B"/>
+                  <a:srgbClr val="DC2626"/>
                 </a:solidFill>
                 <a:latin typeface="Sarabun"/>
               </a:defRPr>
@@ -7529,7 +7830,7 @@
               </a:spcBef>
               <a:defRPr sz="1400">
                 <a:solidFill>
-                  <a:srgbClr val="7F1D1D"/>
+                  <a:srgbClr val="1E293B"/>
                 </a:solidFill>
                 <a:latin typeface="Sarabun"/>
               </a:defRPr>
@@ -7573,7 +7874,7 @@
               </a:spcBef>
               <a:defRPr sz="1400" b="1">
                 <a:solidFill>
-                  <a:srgbClr val="991B1B"/>
+                  <a:srgbClr val="DC2626"/>
                 </a:solidFill>
                 <a:latin typeface="Sarabun"/>
               </a:defRPr>
@@ -7608,7 +7909,50 @@
       <p:grpSpPr/>
       <p:sp>
         <p:nvSpPr>
-          <p:cNvPr id="2" name="TextBox 1"/>
+          <p:cNvPr id="2" name="Rectangle 1"/>
+          <p:cNvSpPr/>
+          <p:nvPr/>
+        </p:nvSpPr>
+        <p:spPr>
+          <a:xfrm>
+            <a:off x="0" y="0"/>
+            <a:ext cx="12191695" cy="6858000"/>
+          </a:xfrm>
+          <a:prstGeom prst="rect">
+            <a:avLst/>
+          </a:prstGeom>
+          <a:solidFill>
+            <a:srgbClr val="FFFFFF"/>
+          </a:solidFill>
+          <a:ln>
+            <a:noFill/>
+          </a:ln>
+        </p:spPr>
+        <p:style>
+          <a:lnRef idx="1">
+            <a:schemeClr val="accent1"/>
+          </a:lnRef>
+          <a:fillRef idx="3">
+            <a:schemeClr val="accent1"/>
+          </a:fillRef>
+          <a:effectRef idx="2">
+            <a:schemeClr val="accent1"/>
+          </a:effectRef>
+          <a:fontRef idx="minor">
+            <a:schemeClr val="lt1"/>
+          </a:fontRef>
+        </p:style>
+        <p:txBody>
+          <a:bodyPr rtlCol="0" anchor="ctr"/>
+          <a:lstStyle/>
+          <a:p>
+            <a:pPr algn="ctr"/>
+          </a:p>
+        </p:txBody>
+      </p:sp>
+      <p:sp>
+        <p:nvSpPr>
+          <p:cNvPr id="3" name="TextBox 2"/>
           <p:cNvSpPr txBox="1"/>
           <p:nvPr/>
         </p:nvSpPr>
@@ -7660,7 +8004,7 @@
       </p:sp>
       <p:sp>
         <p:nvSpPr>
-          <p:cNvPr id="3" name="TextBox 2"/>
+          <p:cNvPr id="4" name="TextBox 3"/>
           <p:cNvSpPr txBox="1"/>
           <p:nvPr/>
         </p:nvSpPr>
@@ -7696,7 +8040,7 @@
       </p:sp>
       <p:sp>
         <p:nvSpPr>
-          <p:cNvPr id="4" name="Rectangle 3"/>
+          <p:cNvPr id="5" name="Rectangle 4"/>
           <p:cNvSpPr/>
           <p:nvPr/>
         </p:nvSpPr>
@@ -7741,7 +8085,7 @@
       </p:sp>
       <p:sp>
         <p:nvSpPr>
-          <p:cNvPr id="5" name="Rounded Rectangle 4"/>
+          <p:cNvPr id="6" name="Rounded Rectangle 5"/>
           <p:cNvSpPr/>
           <p:nvPr/>
         </p:nvSpPr>
@@ -7816,7 +8160,7 @@
       </p:sp>
       <p:sp>
         <p:nvSpPr>
-          <p:cNvPr id="6" name="Rounded Rectangle 5"/>
+          <p:cNvPr id="7" name="Rounded Rectangle 6"/>
           <p:cNvSpPr/>
           <p:nvPr/>
         </p:nvSpPr>
@@ -7891,7 +8235,7 @@
       </p:sp>
       <p:sp>
         <p:nvSpPr>
-          <p:cNvPr id="7" name="Rounded Rectangle 6"/>
+          <p:cNvPr id="8" name="Rounded Rectangle 7"/>
           <p:cNvSpPr/>
           <p:nvPr/>
         </p:nvSpPr>

</xml_diff>